<commit_message>
Remove company name from presentation (neutral branding)
Replace the wordmark with a neutral yellow beam accent on every slide and
drop company-name references from the docs. Palette unchanged.

Co-Authored-By: Claude Opus 4.8 <noreply@anthropic.com>
Claude-Session: https://claude.ai/code/session_01JQVZ2FVwvC1NPNKyKDE48A
</commit_message>
<xml_diff>
--- a/presentation/Contract360_Manager_Deck.pptx
+++ b/presentation/Contract360_Manager_Deck.pptx
@@ -3930,49 +3930,14 @@
       </p:sp>
       <p:sp>
         <p:nvSpPr>
-          <p:cNvPr id="5" name="TextBox 4"/>
-          <p:cNvSpPr txBox="1"/>
-          <p:nvPr/>
-        </p:nvSpPr>
-        <p:spPr>
-          <a:xfrm>
-            <a:off x="548640" y="502920"/>
-            <a:ext cx="845820" cy="525780"/>
-          </a:xfrm>
-          <a:prstGeom prst="rect">
-            <a:avLst/>
-          </a:prstGeom>
-          <a:noFill/>
-        </p:spPr>
-        <p:txBody>
-          <a:bodyPr wrap="none" lIns="0" tIns="0" bIns="0">
-            <a:spAutoFit/>
-          </a:bodyPr>
-          <a:lstStyle/>
-          <a:p>
-            <a:pPr algn="l"/>
-            <a:r>
-              <a:rPr sz="3250" b="1">
-                <a:solidFill>
-                  <a:srgbClr val="FFFFFF"/>
-                </a:solidFill>
-                <a:latin typeface="Arial"/>
-              </a:rPr>
-              <a:t>EY</a:t>
-            </a:r>
-          </a:p>
-        </p:txBody>
-      </p:sp>
-      <p:sp>
-        <p:nvSpPr>
-          <p:cNvPr id="6" name="Parallelogram 5"/>
+          <p:cNvPr id="5" name="Parallelogram 4"/>
           <p:cNvSpPr/>
           <p:nvPr/>
         </p:nvSpPr>
         <p:spPr>
           <a:xfrm>
-            <a:off x="548640" y="960120"/>
-            <a:ext cx="754380" cy="137160"/>
+            <a:off x="548640" y="708659"/>
+            <a:ext cx="822959" cy="160020"/>
           </a:xfrm>
           <a:prstGeom prst="parallelogram">
             <a:avLst>
@@ -4011,7 +3976,7 @@
       </p:sp>
       <p:sp>
         <p:nvSpPr>
-          <p:cNvPr id="7" name="TextBox 6"/>
+          <p:cNvPr id="6" name="TextBox 5"/>
           <p:cNvSpPr txBox="1"/>
           <p:nvPr/>
         </p:nvSpPr>
@@ -4056,7 +4021,7 @@
       </p:sp>
       <p:sp>
         <p:nvSpPr>
-          <p:cNvPr id="8" name="TextBox 7"/>
+          <p:cNvPr id="7" name="TextBox 6"/>
           <p:cNvSpPr txBox="1"/>
           <p:nvPr/>
         </p:nvSpPr>
@@ -4101,7 +4066,7 @@
       </p:sp>
       <p:sp>
         <p:nvSpPr>
-          <p:cNvPr id="9" name="TextBox 8"/>
+          <p:cNvPr id="8" name="TextBox 7"/>
           <p:cNvSpPr txBox="1"/>
           <p:nvPr/>
         </p:nvSpPr>
@@ -4168,7 +4133,7 @@
       </p:sp>
       <p:sp>
         <p:nvSpPr>
-          <p:cNvPr id="10" name="TextBox 9"/>
+          <p:cNvPr id="9" name="TextBox 8"/>
           <p:cNvSpPr txBox="1"/>
           <p:nvPr/>
         </p:nvSpPr>
@@ -4409,49 +4374,14 @@
       </p:sp>
       <p:sp>
         <p:nvSpPr>
-          <p:cNvPr id="6" name="TextBox 5"/>
-          <p:cNvSpPr txBox="1"/>
-          <p:nvPr/>
-        </p:nvSpPr>
-        <p:spPr>
-          <a:xfrm>
-            <a:off x="11201400" y="274320"/>
-            <a:ext cx="575157" cy="357530"/>
-          </a:xfrm>
-          <a:prstGeom prst="rect">
-            <a:avLst/>
-          </a:prstGeom>
-          <a:noFill/>
-        </p:spPr>
-        <p:txBody>
-          <a:bodyPr wrap="none" lIns="0" tIns="0" bIns="0">
-            <a:spAutoFit/>
-          </a:bodyPr>
-          <a:lstStyle/>
-          <a:p>
-            <a:pPr algn="l"/>
-            <a:r>
-              <a:rPr sz="2210" b="1">
-                <a:solidFill>
-                  <a:srgbClr val="FFFFFF"/>
-                </a:solidFill>
-                <a:latin typeface="Arial"/>
-              </a:rPr>
-              <a:t>EY</a:t>
-            </a:r>
-          </a:p>
-        </p:txBody>
-      </p:sp>
-      <p:sp>
-        <p:nvSpPr>
-          <p:cNvPr id="7" name="Parallelogram 6"/>
+          <p:cNvPr id="6" name="Parallelogram 5"/>
           <p:cNvSpPr/>
           <p:nvPr/>
         </p:nvSpPr>
         <p:spPr>
           <a:xfrm>
-            <a:off x="11201400" y="585216"/>
-            <a:ext cx="512978" cy="93268"/>
+            <a:off x="11201400" y="414223"/>
+            <a:ext cx="559612" cy="108813"/>
           </a:xfrm>
           <a:prstGeom prst="parallelogram">
             <a:avLst>
@@ -4490,7 +4420,7 @@
       </p:sp>
       <p:sp>
         <p:nvSpPr>
-          <p:cNvPr id="8" name="TextBox 7"/>
+          <p:cNvPr id="7" name="TextBox 6"/>
           <p:cNvSpPr txBox="1"/>
           <p:nvPr/>
         </p:nvSpPr>
@@ -4535,7 +4465,7 @@
       </p:sp>
       <p:sp>
         <p:nvSpPr>
-          <p:cNvPr id="9" name="TextBox 8"/>
+          <p:cNvPr id="8" name="TextBox 7"/>
           <p:cNvSpPr txBox="1"/>
           <p:nvPr/>
         </p:nvSpPr>
@@ -4580,7 +4510,7 @@
       </p:sp>
       <p:sp>
         <p:nvSpPr>
-          <p:cNvPr id="10" name="Rectangle 9"/>
+          <p:cNvPr id="9" name="Rectangle 8"/>
           <p:cNvSpPr/>
           <p:nvPr/>
         </p:nvSpPr>
@@ -4624,7 +4554,7 @@
       </p:sp>
       <p:sp>
         <p:nvSpPr>
-          <p:cNvPr id="11" name="Rectangle 10"/>
+          <p:cNvPr id="10" name="Rectangle 9"/>
           <p:cNvSpPr/>
           <p:nvPr/>
         </p:nvSpPr>
@@ -4668,7 +4598,7 @@
       </p:sp>
       <p:sp>
         <p:nvSpPr>
-          <p:cNvPr id="12" name="TextBox 11"/>
+          <p:cNvPr id="11" name="TextBox 10"/>
           <p:cNvSpPr txBox="1"/>
           <p:nvPr/>
         </p:nvSpPr>
@@ -4713,7 +4643,7 @@
       </p:sp>
       <p:sp>
         <p:nvSpPr>
-          <p:cNvPr id="13" name="TextBox 12"/>
+          <p:cNvPr id="12" name="TextBox 11"/>
           <p:cNvSpPr txBox="1"/>
           <p:nvPr/>
         </p:nvSpPr>
@@ -4856,7 +4786,7 @@
       </p:sp>
       <p:sp>
         <p:nvSpPr>
-          <p:cNvPr id="14" name="Rectangle 13"/>
+          <p:cNvPr id="13" name="Rectangle 12"/>
           <p:cNvSpPr/>
           <p:nvPr/>
         </p:nvSpPr>
@@ -4900,7 +4830,7 @@
       </p:sp>
       <p:sp>
         <p:nvSpPr>
-          <p:cNvPr id="15" name="Rectangle 14"/>
+          <p:cNvPr id="14" name="Rectangle 13"/>
           <p:cNvSpPr/>
           <p:nvPr/>
         </p:nvSpPr>
@@ -4944,7 +4874,7 @@
       </p:sp>
       <p:sp>
         <p:nvSpPr>
-          <p:cNvPr id="16" name="TextBox 15"/>
+          <p:cNvPr id="15" name="TextBox 14"/>
           <p:cNvSpPr txBox="1"/>
           <p:nvPr/>
         </p:nvSpPr>
@@ -4989,7 +4919,7 @@
       </p:sp>
       <p:sp>
         <p:nvSpPr>
-          <p:cNvPr id="17" name="TextBox 16"/>
+          <p:cNvPr id="16" name="TextBox 15"/>
           <p:cNvSpPr txBox="1"/>
           <p:nvPr/>
         </p:nvSpPr>
@@ -5132,7 +5062,7 @@
       </p:sp>
       <p:sp>
         <p:nvSpPr>
-          <p:cNvPr id="18" name="Rectangle 17"/>
+          <p:cNvPr id="17" name="Rectangle 16"/>
           <p:cNvSpPr/>
           <p:nvPr/>
         </p:nvSpPr>
@@ -5176,7 +5106,7 @@
       </p:sp>
       <p:sp>
         <p:nvSpPr>
-          <p:cNvPr id="19" name="Rectangle 18"/>
+          <p:cNvPr id="18" name="Rectangle 17"/>
           <p:cNvSpPr/>
           <p:nvPr/>
         </p:nvSpPr>
@@ -5220,7 +5150,7 @@
       </p:sp>
       <p:sp>
         <p:nvSpPr>
-          <p:cNvPr id="20" name="TextBox 19"/>
+          <p:cNvPr id="19" name="TextBox 18"/>
           <p:cNvSpPr txBox="1"/>
           <p:nvPr/>
         </p:nvSpPr>
@@ -5265,7 +5195,7 @@
       </p:sp>
       <p:sp>
         <p:nvSpPr>
-          <p:cNvPr id="21" name="TextBox 20"/>
+          <p:cNvPr id="20" name="TextBox 19"/>
           <p:cNvSpPr txBox="1"/>
           <p:nvPr/>
         </p:nvSpPr>
@@ -5408,7 +5338,7 @@
       </p:sp>
       <p:sp>
         <p:nvSpPr>
-          <p:cNvPr id="22" name="Rectangle 21"/>
+          <p:cNvPr id="21" name="Rectangle 20"/>
           <p:cNvSpPr/>
           <p:nvPr/>
         </p:nvSpPr>
@@ -5452,7 +5382,7 @@
       </p:sp>
       <p:sp>
         <p:nvSpPr>
-          <p:cNvPr id="23" name="Rectangle 22"/>
+          <p:cNvPr id="22" name="Rectangle 21"/>
           <p:cNvSpPr/>
           <p:nvPr/>
         </p:nvSpPr>
@@ -5496,7 +5426,7 @@
       </p:sp>
       <p:sp>
         <p:nvSpPr>
-          <p:cNvPr id="24" name="TextBox 23"/>
+          <p:cNvPr id="23" name="TextBox 22"/>
           <p:cNvSpPr txBox="1"/>
           <p:nvPr/>
         </p:nvSpPr>
@@ -5541,7 +5471,7 @@
       </p:sp>
       <p:sp>
         <p:nvSpPr>
-          <p:cNvPr id="25" name="TextBox 24"/>
+          <p:cNvPr id="24" name="TextBox 23"/>
           <p:cNvSpPr txBox="1"/>
           <p:nvPr/>
         </p:nvSpPr>
@@ -5586,7 +5516,7 @@
       </p:sp>
       <p:sp>
         <p:nvSpPr>
-          <p:cNvPr id="26" name="Rounded Rectangle 25"/>
+          <p:cNvPr id="25" name="Rounded Rectangle 24"/>
           <p:cNvSpPr/>
           <p:nvPr/>
         </p:nvSpPr>
@@ -5641,7 +5571,7 @@
       </p:sp>
       <p:sp>
         <p:nvSpPr>
-          <p:cNvPr id="27" name="Rounded Rectangle 26"/>
+          <p:cNvPr id="26" name="Rounded Rectangle 25"/>
           <p:cNvSpPr/>
           <p:nvPr/>
         </p:nvSpPr>
@@ -5696,7 +5626,7 @@
       </p:sp>
       <p:sp>
         <p:nvSpPr>
-          <p:cNvPr id="28" name="Rounded Rectangle 27"/>
+          <p:cNvPr id="27" name="Rounded Rectangle 26"/>
           <p:cNvSpPr/>
           <p:nvPr/>
         </p:nvSpPr>
@@ -5751,7 +5681,7 @@
       </p:sp>
       <p:sp>
         <p:nvSpPr>
-          <p:cNvPr id="29" name="Rounded Rectangle 28"/>
+          <p:cNvPr id="28" name="Rounded Rectangle 27"/>
           <p:cNvSpPr/>
           <p:nvPr/>
         </p:nvSpPr>
@@ -5806,7 +5736,7 @@
       </p:sp>
       <p:sp>
         <p:nvSpPr>
-          <p:cNvPr id="30" name="TextBox 29"/>
+          <p:cNvPr id="29" name="TextBox 28"/>
           <p:cNvSpPr txBox="1"/>
           <p:nvPr/>
         </p:nvSpPr>
@@ -5851,7 +5781,7 @@
       </p:sp>
       <p:sp>
         <p:nvSpPr>
-          <p:cNvPr id="31" name="Rounded Rectangle 30"/>
+          <p:cNvPr id="30" name="Rounded Rectangle 29"/>
           <p:cNvSpPr/>
           <p:nvPr/>
         </p:nvSpPr>
@@ -5906,7 +5836,7 @@
       </p:sp>
       <p:sp>
         <p:nvSpPr>
-          <p:cNvPr id="32" name="Rounded Rectangle 31"/>
+          <p:cNvPr id="31" name="Rounded Rectangle 30"/>
           <p:cNvSpPr/>
           <p:nvPr/>
         </p:nvSpPr>
@@ -5961,7 +5891,7 @@
       </p:sp>
       <p:sp>
         <p:nvSpPr>
-          <p:cNvPr id="33" name="TextBox 32"/>
+          <p:cNvPr id="32" name="TextBox 31"/>
           <p:cNvSpPr txBox="1"/>
           <p:nvPr/>
         </p:nvSpPr>
@@ -6006,7 +5936,7 @@
       </p:sp>
       <p:sp>
         <p:nvSpPr>
-          <p:cNvPr id="34" name="Rounded Rectangle 33"/>
+          <p:cNvPr id="33" name="Rounded Rectangle 32"/>
           <p:cNvSpPr/>
           <p:nvPr/>
         </p:nvSpPr>
@@ -6061,7 +5991,7 @@
       </p:sp>
       <p:sp>
         <p:nvSpPr>
-          <p:cNvPr id="35" name="Rounded Rectangle 34"/>
+          <p:cNvPr id="34" name="Rounded Rectangle 33"/>
           <p:cNvSpPr/>
           <p:nvPr/>
         </p:nvSpPr>
@@ -6116,7 +6046,7 @@
       </p:sp>
       <p:sp>
         <p:nvSpPr>
-          <p:cNvPr id="36" name="Rounded Rectangle 35"/>
+          <p:cNvPr id="35" name="Rounded Rectangle 34"/>
           <p:cNvSpPr/>
           <p:nvPr/>
         </p:nvSpPr>
@@ -6171,7 +6101,7 @@
       </p:sp>
       <p:sp>
         <p:nvSpPr>
-          <p:cNvPr id="37" name="Rounded Rectangle 36"/>
+          <p:cNvPr id="36" name="Rounded Rectangle 35"/>
           <p:cNvSpPr/>
           <p:nvPr/>
         </p:nvSpPr>
@@ -6226,7 +6156,7 @@
       </p:sp>
       <p:sp>
         <p:nvSpPr>
-          <p:cNvPr id="38" name="TextBox 37"/>
+          <p:cNvPr id="37" name="TextBox 36"/>
           <p:cNvSpPr txBox="1"/>
           <p:nvPr/>
         </p:nvSpPr>
@@ -6271,7 +6201,7 @@
       </p:sp>
       <p:sp>
         <p:nvSpPr>
-          <p:cNvPr id="39" name="Rounded Rectangle 38"/>
+          <p:cNvPr id="38" name="Rounded Rectangle 37"/>
           <p:cNvSpPr/>
           <p:nvPr/>
         </p:nvSpPr>
@@ -6326,7 +6256,7 @@
       </p:sp>
       <p:sp>
         <p:nvSpPr>
-          <p:cNvPr id="40" name="Rounded Rectangle 39"/>
+          <p:cNvPr id="39" name="Rounded Rectangle 38"/>
           <p:cNvSpPr/>
           <p:nvPr/>
         </p:nvSpPr>
@@ -6577,49 +6507,14 @@
       </p:sp>
       <p:sp>
         <p:nvSpPr>
-          <p:cNvPr id="6" name="TextBox 5"/>
-          <p:cNvSpPr txBox="1"/>
-          <p:nvPr/>
-        </p:nvSpPr>
-        <p:spPr>
-          <a:xfrm>
-            <a:off x="11201400" y="274320"/>
-            <a:ext cx="575157" cy="357530"/>
-          </a:xfrm>
-          <a:prstGeom prst="rect">
-            <a:avLst/>
-          </a:prstGeom>
-          <a:noFill/>
-        </p:spPr>
-        <p:txBody>
-          <a:bodyPr wrap="none" lIns="0" tIns="0" bIns="0">
-            <a:spAutoFit/>
-          </a:bodyPr>
-          <a:lstStyle/>
-          <a:p>
-            <a:pPr algn="l"/>
-            <a:r>
-              <a:rPr sz="2210" b="1">
-                <a:solidFill>
-                  <a:srgbClr val="FFFFFF"/>
-                </a:solidFill>
-                <a:latin typeface="Arial"/>
-              </a:rPr>
-              <a:t>EY</a:t>
-            </a:r>
-          </a:p>
-        </p:txBody>
-      </p:sp>
-      <p:sp>
-        <p:nvSpPr>
-          <p:cNvPr id="7" name="Parallelogram 6"/>
+          <p:cNvPr id="6" name="Parallelogram 5"/>
           <p:cNvSpPr/>
           <p:nvPr/>
         </p:nvSpPr>
         <p:spPr>
           <a:xfrm>
-            <a:off x="11201400" y="585216"/>
-            <a:ext cx="512978" cy="93268"/>
+            <a:off x="11201400" y="414223"/>
+            <a:ext cx="559612" cy="108813"/>
           </a:xfrm>
           <a:prstGeom prst="parallelogram">
             <a:avLst>
@@ -6658,7 +6553,7 @@
       </p:sp>
       <p:sp>
         <p:nvSpPr>
-          <p:cNvPr id="8" name="TextBox 7"/>
+          <p:cNvPr id="7" name="TextBox 6"/>
           <p:cNvSpPr txBox="1"/>
           <p:nvPr/>
         </p:nvSpPr>
@@ -6703,7 +6598,7 @@
       </p:sp>
       <p:sp>
         <p:nvSpPr>
-          <p:cNvPr id="9" name="TextBox 8"/>
+          <p:cNvPr id="8" name="TextBox 7"/>
           <p:cNvSpPr txBox="1"/>
           <p:nvPr/>
         </p:nvSpPr>
@@ -6748,7 +6643,7 @@
       </p:sp>
       <p:pic>
         <p:nvPicPr>
-          <p:cNvPr id="10" name="Picture 9" descr="hl_arch.png"/>
+          <p:cNvPr id="9" name="Picture 8" descr="hl_arch.png"/>
           <p:cNvPicPr>
             <a:picLocks noChangeAspect="1"/>
           </p:cNvPicPr>
@@ -6772,7 +6667,7 @@
       </p:pic>
       <p:sp>
         <p:nvSpPr>
-          <p:cNvPr id="11" name="Rectangle 10"/>
+          <p:cNvPr id="10" name="Rectangle 9"/>
           <p:cNvSpPr/>
           <p:nvPr/>
         </p:nvSpPr>
@@ -6816,7 +6711,7 @@
       </p:sp>
       <p:sp>
         <p:nvSpPr>
-          <p:cNvPr id="12" name="TextBox 11"/>
+          <p:cNvPr id="11" name="TextBox 10"/>
           <p:cNvSpPr txBox="1"/>
           <p:nvPr/>
         </p:nvSpPr>
@@ -6883,7 +6778,7 @@
       </p:sp>
       <p:sp>
         <p:nvSpPr>
-          <p:cNvPr id="13" name="Rectangle 12"/>
+          <p:cNvPr id="12" name="Rectangle 11"/>
           <p:cNvSpPr/>
           <p:nvPr/>
         </p:nvSpPr>
@@ -6927,7 +6822,7 @@
       </p:sp>
       <p:sp>
         <p:nvSpPr>
-          <p:cNvPr id="14" name="TextBox 13"/>
+          <p:cNvPr id="13" name="TextBox 12"/>
           <p:cNvSpPr txBox="1"/>
           <p:nvPr/>
         </p:nvSpPr>
@@ -6994,7 +6889,7 @@
       </p:sp>
       <p:sp>
         <p:nvSpPr>
-          <p:cNvPr id="15" name="Rectangle 14"/>
+          <p:cNvPr id="14" name="Rectangle 13"/>
           <p:cNvSpPr/>
           <p:nvPr/>
         </p:nvSpPr>
@@ -7038,7 +6933,7 @@
       </p:sp>
       <p:sp>
         <p:nvSpPr>
-          <p:cNvPr id="16" name="TextBox 15"/>
+          <p:cNvPr id="15" name="TextBox 14"/>
           <p:cNvSpPr txBox="1"/>
           <p:nvPr/>
         </p:nvSpPr>
@@ -7301,49 +7196,14 @@
       </p:sp>
       <p:sp>
         <p:nvSpPr>
-          <p:cNvPr id="6" name="TextBox 5"/>
-          <p:cNvSpPr txBox="1"/>
-          <p:nvPr/>
-        </p:nvSpPr>
-        <p:spPr>
-          <a:xfrm>
-            <a:off x="11201400" y="274320"/>
-            <a:ext cx="575157" cy="357530"/>
-          </a:xfrm>
-          <a:prstGeom prst="rect">
-            <a:avLst/>
-          </a:prstGeom>
-          <a:noFill/>
-        </p:spPr>
-        <p:txBody>
-          <a:bodyPr wrap="none" lIns="0" tIns="0" bIns="0">
-            <a:spAutoFit/>
-          </a:bodyPr>
-          <a:lstStyle/>
-          <a:p>
-            <a:pPr algn="l"/>
-            <a:r>
-              <a:rPr sz="2210" b="1">
-                <a:solidFill>
-                  <a:srgbClr val="FFFFFF"/>
-                </a:solidFill>
-                <a:latin typeface="Arial"/>
-              </a:rPr>
-              <a:t>EY</a:t>
-            </a:r>
-          </a:p>
-        </p:txBody>
-      </p:sp>
-      <p:sp>
-        <p:nvSpPr>
-          <p:cNvPr id="7" name="Parallelogram 6"/>
+          <p:cNvPr id="6" name="Parallelogram 5"/>
           <p:cNvSpPr/>
           <p:nvPr/>
         </p:nvSpPr>
         <p:spPr>
           <a:xfrm>
-            <a:off x="11201400" y="585216"/>
-            <a:ext cx="512978" cy="93268"/>
+            <a:off x="11201400" y="414223"/>
+            <a:ext cx="559612" cy="108813"/>
           </a:xfrm>
           <a:prstGeom prst="parallelogram">
             <a:avLst>
@@ -7382,7 +7242,7 @@
       </p:sp>
       <p:sp>
         <p:nvSpPr>
-          <p:cNvPr id="8" name="TextBox 7"/>
+          <p:cNvPr id="7" name="TextBox 6"/>
           <p:cNvSpPr txBox="1"/>
           <p:nvPr/>
         </p:nvSpPr>
@@ -7427,7 +7287,7 @@
       </p:sp>
       <p:sp>
         <p:nvSpPr>
-          <p:cNvPr id="9" name="TextBox 8"/>
+          <p:cNvPr id="8" name="TextBox 7"/>
           <p:cNvSpPr txBox="1"/>
           <p:nvPr/>
         </p:nvSpPr>
@@ -7472,7 +7332,7 @@
       </p:sp>
       <p:pic>
         <p:nvPicPr>
-          <p:cNvPr id="10" name="Picture 9" descr="detail_arch.png"/>
+          <p:cNvPr id="9" name="Picture 8" descr="detail_arch.png"/>
           <p:cNvPicPr>
             <a:picLocks noChangeAspect="1"/>
           </p:cNvPicPr>
@@ -7496,7 +7356,7 @@
       </p:pic>
       <p:sp>
         <p:nvSpPr>
-          <p:cNvPr id="11" name="TextBox 10"/>
+          <p:cNvPr id="10" name="TextBox 9"/>
           <p:cNvSpPr txBox="1"/>
           <p:nvPr/>
         </p:nvSpPr>
@@ -7541,7 +7401,7 @@
       </p:sp>
       <p:sp>
         <p:nvSpPr>
-          <p:cNvPr id="12" name="Rectangle 11"/>
+          <p:cNvPr id="11" name="Rectangle 10"/>
           <p:cNvSpPr/>
           <p:nvPr/>
         </p:nvSpPr>
@@ -7585,7 +7445,7 @@
       </p:sp>
       <p:sp>
         <p:nvSpPr>
-          <p:cNvPr id="13" name="TextBox 12"/>
+          <p:cNvPr id="12" name="TextBox 11"/>
           <p:cNvSpPr txBox="1"/>
           <p:nvPr/>
         </p:nvSpPr>
@@ -7652,7 +7512,7 @@
       </p:sp>
       <p:sp>
         <p:nvSpPr>
-          <p:cNvPr id="14" name="Rectangle 13"/>
+          <p:cNvPr id="13" name="Rectangle 12"/>
           <p:cNvSpPr/>
           <p:nvPr/>
         </p:nvSpPr>
@@ -7696,7 +7556,7 @@
       </p:sp>
       <p:sp>
         <p:nvSpPr>
-          <p:cNvPr id="15" name="TextBox 14"/>
+          <p:cNvPr id="14" name="TextBox 13"/>
           <p:cNvSpPr txBox="1"/>
           <p:nvPr/>
         </p:nvSpPr>
@@ -7763,7 +7623,7 @@
       </p:sp>
       <p:sp>
         <p:nvSpPr>
-          <p:cNvPr id="16" name="Rectangle 15"/>
+          <p:cNvPr id="15" name="Rectangle 14"/>
           <p:cNvSpPr/>
           <p:nvPr/>
         </p:nvSpPr>
@@ -7807,7 +7667,7 @@
       </p:sp>
       <p:sp>
         <p:nvSpPr>
-          <p:cNvPr id="17" name="TextBox 16"/>
+          <p:cNvPr id="16" name="TextBox 15"/>
           <p:cNvSpPr txBox="1"/>
           <p:nvPr/>
         </p:nvSpPr>
@@ -7874,7 +7734,7 @@
       </p:sp>
       <p:sp>
         <p:nvSpPr>
-          <p:cNvPr id="18" name="Rectangle 17"/>
+          <p:cNvPr id="17" name="Rectangle 16"/>
           <p:cNvSpPr/>
           <p:nvPr/>
         </p:nvSpPr>
@@ -7918,7 +7778,7 @@
       </p:sp>
       <p:sp>
         <p:nvSpPr>
-          <p:cNvPr id="19" name="TextBox 18"/>
+          <p:cNvPr id="18" name="TextBox 17"/>
           <p:cNvSpPr txBox="1"/>
           <p:nvPr/>
         </p:nvSpPr>
@@ -7985,7 +7845,7 @@
       </p:sp>
       <p:sp>
         <p:nvSpPr>
-          <p:cNvPr id="20" name="Rectangle 19"/>
+          <p:cNvPr id="19" name="Rectangle 18"/>
           <p:cNvSpPr/>
           <p:nvPr/>
         </p:nvSpPr>
@@ -8029,7 +7889,7 @@
       </p:sp>
       <p:sp>
         <p:nvSpPr>
-          <p:cNvPr id="21" name="TextBox 20"/>
+          <p:cNvPr id="20" name="TextBox 19"/>
           <p:cNvSpPr txBox="1"/>
           <p:nvPr/>
         </p:nvSpPr>
@@ -8096,7 +7956,7 @@
       </p:sp>
       <p:sp>
         <p:nvSpPr>
-          <p:cNvPr id="22" name="Rectangle 21"/>
+          <p:cNvPr id="21" name="Rectangle 20"/>
           <p:cNvSpPr/>
           <p:nvPr/>
         </p:nvSpPr>
@@ -8140,7 +8000,7 @@
       </p:sp>
       <p:sp>
         <p:nvSpPr>
-          <p:cNvPr id="23" name="TextBox 22"/>
+          <p:cNvPr id="22" name="TextBox 21"/>
           <p:cNvSpPr txBox="1"/>
           <p:nvPr/>
         </p:nvSpPr>
@@ -8207,7 +8067,7 @@
       </p:sp>
       <p:sp>
         <p:nvSpPr>
-          <p:cNvPr id="24" name="TextBox 23"/>
+          <p:cNvPr id="23" name="TextBox 22"/>
           <p:cNvSpPr txBox="1"/>
           <p:nvPr/>
         </p:nvSpPr>
@@ -8252,7 +8112,7 @@
       </p:sp>
       <p:sp>
         <p:nvSpPr>
-          <p:cNvPr id="25" name="Rectangle 24"/>
+          <p:cNvPr id="24" name="Rectangle 23"/>
           <p:cNvSpPr/>
           <p:nvPr/>
         </p:nvSpPr>
@@ -8296,7 +8156,7 @@
       </p:sp>
       <p:sp>
         <p:nvSpPr>
-          <p:cNvPr id="26" name="TextBox 25"/>
+          <p:cNvPr id="25" name="TextBox 24"/>
           <p:cNvSpPr txBox="1"/>
           <p:nvPr/>
         </p:nvSpPr>
@@ -8363,7 +8223,7 @@
       </p:sp>
       <p:sp>
         <p:nvSpPr>
-          <p:cNvPr id="27" name="Rectangle 26"/>
+          <p:cNvPr id="26" name="Rectangle 25"/>
           <p:cNvSpPr/>
           <p:nvPr/>
         </p:nvSpPr>
@@ -8407,7 +8267,7 @@
       </p:sp>
       <p:sp>
         <p:nvSpPr>
-          <p:cNvPr id="28" name="TextBox 27"/>
+          <p:cNvPr id="27" name="TextBox 26"/>
           <p:cNvSpPr txBox="1"/>
           <p:nvPr/>
         </p:nvSpPr>
@@ -8474,7 +8334,7 @@
       </p:sp>
       <p:sp>
         <p:nvSpPr>
-          <p:cNvPr id="29" name="Rectangle 28"/>
+          <p:cNvPr id="28" name="Rectangle 27"/>
           <p:cNvSpPr/>
           <p:nvPr/>
         </p:nvSpPr>
@@ -8518,7 +8378,7 @@
       </p:sp>
       <p:sp>
         <p:nvSpPr>
-          <p:cNvPr id="30" name="TextBox 29"/>
+          <p:cNvPr id="29" name="TextBox 28"/>
           <p:cNvSpPr txBox="1"/>
           <p:nvPr/>
         </p:nvSpPr>
@@ -8585,7 +8445,7 @@
       </p:sp>
       <p:sp>
         <p:nvSpPr>
-          <p:cNvPr id="31" name="Rectangle 30"/>
+          <p:cNvPr id="30" name="Rectangle 29"/>
           <p:cNvSpPr/>
           <p:nvPr/>
         </p:nvSpPr>
@@ -8629,7 +8489,7 @@
       </p:sp>
       <p:sp>
         <p:nvSpPr>
-          <p:cNvPr id="32" name="TextBox 31"/>
+          <p:cNvPr id="31" name="TextBox 30"/>
           <p:cNvSpPr txBox="1"/>
           <p:nvPr/>
         </p:nvSpPr>
@@ -8696,7 +8556,7 @@
       </p:sp>
       <p:sp>
         <p:nvSpPr>
-          <p:cNvPr id="33" name="Rectangle 32"/>
+          <p:cNvPr id="32" name="Rectangle 31"/>
           <p:cNvSpPr/>
           <p:nvPr/>
         </p:nvSpPr>
@@ -8740,7 +8600,7 @@
       </p:sp>
       <p:sp>
         <p:nvSpPr>
-          <p:cNvPr id="34" name="TextBox 33"/>
+          <p:cNvPr id="33" name="TextBox 32"/>
           <p:cNvSpPr txBox="1"/>
           <p:nvPr/>
         </p:nvSpPr>
@@ -9003,49 +8863,14 @@
       </p:sp>
       <p:sp>
         <p:nvSpPr>
-          <p:cNvPr id="6" name="TextBox 5"/>
-          <p:cNvSpPr txBox="1"/>
-          <p:nvPr/>
-        </p:nvSpPr>
-        <p:spPr>
-          <a:xfrm>
-            <a:off x="11201400" y="274320"/>
-            <a:ext cx="575157" cy="357530"/>
-          </a:xfrm>
-          <a:prstGeom prst="rect">
-            <a:avLst/>
-          </a:prstGeom>
-          <a:noFill/>
-        </p:spPr>
-        <p:txBody>
-          <a:bodyPr wrap="none" lIns="0" tIns="0" bIns="0">
-            <a:spAutoFit/>
-          </a:bodyPr>
-          <a:lstStyle/>
-          <a:p>
-            <a:pPr algn="l"/>
-            <a:r>
-              <a:rPr sz="2210" b="1">
-                <a:solidFill>
-                  <a:srgbClr val="FFFFFF"/>
-                </a:solidFill>
-                <a:latin typeface="Arial"/>
-              </a:rPr>
-              <a:t>EY</a:t>
-            </a:r>
-          </a:p>
-        </p:txBody>
-      </p:sp>
-      <p:sp>
-        <p:nvSpPr>
-          <p:cNvPr id="7" name="Parallelogram 6"/>
+          <p:cNvPr id="6" name="Parallelogram 5"/>
           <p:cNvSpPr/>
           <p:nvPr/>
         </p:nvSpPr>
         <p:spPr>
           <a:xfrm>
-            <a:off x="11201400" y="585216"/>
-            <a:ext cx="512978" cy="93268"/>
+            <a:off x="11201400" y="414223"/>
+            <a:ext cx="559612" cy="108813"/>
           </a:xfrm>
           <a:prstGeom prst="parallelogram">
             <a:avLst>
@@ -9084,7 +8909,7 @@
       </p:sp>
       <p:sp>
         <p:nvSpPr>
-          <p:cNvPr id="8" name="TextBox 7"/>
+          <p:cNvPr id="7" name="TextBox 6"/>
           <p:cNvSpPr txBox="1"/>
           <p:nvPr/>
         </p:nvSpPr>
@@ -9129,7 +8954,7 @@
       </p:sp>
       <p:sp>
         <p:nvSpPr>
-          <p:cNvPr id="9" name="TextBox 8"/>
+          <p:cNvPr id="8" name="TextBox 7"/>
           <p:cNvSpPr txBox="1"/>
           <p:nvPr/>
         </p:nvSpPr>
@@ -9174,7 +8999,7 @@
       </p:sp>
       <p:sp>
         <p:nvSpPr>
-          <p:cNvPr id="10" name="Rectangle 9"/>
+          <p:cNvPr id="9" name="Rectangle 8"/>
           <p:cNvSpPr/>
           <p:nvPr/>
         </p:nvSpPr>
@@ -9218,7 +9043,7 @@
       </p:sp>
       <p:sp>
         <p:nvSpPr>
-          <p:cNvPr id="11" name="Rectangle 10"/>
+          <p:cNvPr id="10" name="Rectangle 9"/>
           <p:cNvSpPr/>
           <p:nvPr/>
         </p:nvSpPr>
@@ -9262,7 +9087,7 @@
       </p:sp>
       <p:sp>
         <p:nvSpPr>
-          <p:cNvPr id="12" name="TextBox 11"/>
+          <p:cNvPr id="11" name="TextBox 10"/>
           <p:cNvSpPr txBox="1"/>
           <p:nvPr/>
         </p:nvSpPr>
@@ -9307,7 +9132,7 @@
       </p:sp>
       <p:sp>
         <p:nvSpPr>
-          <p:cNvPr id="13" name="TextBox 12"/>
+          <p:cNvPr id="12" name="TextBox 11"/>
           <p:cNvSpPr txBox="1"/>
           <p:nvPr/>
         </p:nvSpPr>
@@ -9530,7 +9355,7 @@
       </p:sp>
       <p:sp>
         <p:nvSpPr>
-          <p:cNvPr id="14" name="Rectangle 13"/>
+          <p:cNvPr id="13" name="Rectangle 12"/>
           <p:cNvSpPr/>
           <p:nvPr/>
         </p:nvSpPr>
@@ -9574,7 +9399,7 @@
       </p:sp>
       <p:sp>
         <p:nvSpPr>
-          <p:cNvPr id="15" name="Rectangle 14"/>
+          <p:cNvPr id="14" name="Rectangle 13"/>
           <p:cNvSpPr/>
           <p:nvPr/>
         </p:nvSpPr>
@@ -9618,7 +9443,7 @@
       </p:sp>
       <p:sp>
         <p:nvSpPr>
-          <p:cNvPr id="16" name="TextBox 15"/>
+          <p:cNvPr id="15" name="TextBox 14"/>
           <p:cNvSpPr txBox="1"/>
           <p:nvPr/>
         </p:nvSpPr>
@@ -9663,7 +9488,7 @@
       </p:sp>
       <p:sp>
         <p:nvSpPr>
-          <p:cNvPr id="17" name="TextBox 16"/>
+          <p:cNvPr id="16" name="TextBox 15"/>
           <p:cNvSpPr txBox="1"/>
           <p:nvPr/>
         </p:nvSpPr>
@@ -9810,7 +9635,7 @@
       </p:sp>
       <p:sp>
         <p:nvSpPr>
-          <p:cNvPr id="18" name="Rectangle 17"/>
+          <p:cNvPr id="17" name="Rectangle 16"/>
           <p:cNvSpPr/>
           <p:nvPr/>
         </p:nvSpPr>
@@ -9854,7 +9679,7 @@
       </p:sp>
       <p:sp>
         <p:nvSpPr>
-          <p:cNvPr id="19" name="Rectangle 18"/>
+          <p:cNvPr id="18" name="Rectangle 17"/>
           <p:cNvSpPr/>
           <p:nvPr/>
         </p:nvSpPr>
@@ -9898,7 +9723,7 @@
       </p:sp>
       <p:sp>
         <p:nvSpPr>
-          <p:cNvPr id="20" name="TextBox 19"/>
+          <p:cNvPr id="19" name="TextBox 18"/>
           <p:cNvSpPr txBox="1"/>
           <p:nvPr/>
         </p:nvSpPr>
@@ -9943,7 +9768,7 @@
       </p:sp>
       <p:sp>
         <p:nvSpPr>
-          <p:cNvPr id="21" name="TextBox 20"/>
+          <p:cNvPr id="20" name="TextBox 19"/>
           <p:cNvSpPr txBox="1"/>
           <p:nvPr/>
         </p:nvSpPr>
@@ -10019,7 +9844,7 @@
       </p:sp>
       <p:sp>
         <p:nvSpPr>
-          <p:cNvPr id="22" name="Rectangle 21"/>
+          <p:cNvPr id="21" name="Rectangle 20"/>
           <p:cNvSpPr/>
           <p:nvPr/>
         </p:nvSpPr>
@@ -10063,7 +9888,7 @@
       </p:sp>
       <p:sp>
         <p:nvSpPr>
-          <p:cNvPr id="23" name="Rectangle 22"/>
+          <p:cNvPr id="22" name="Rectangle 21"/>
           <p:cNvSpPr/>
           <p:nvPr/>
         </p:nvSpPr>
@@ -10107,7 +9932,7 @@
       </p:sp>
       <p:sp>
         <p:nvSpPr>
-          <p:cNvPr id="24" name="TextBox 23"/>
+          <p:cNvPr id="23" name="TextBox 22"/>
           <p:cNvSpPr txBox="1"/>
           <p:nvPr/>
         </p:nvSpPr>
@@ -10152,7 +9977,7 @@
       </p:sp>
       <p:sp>
         <p:nvSpPr>
-          <p:cNvPr id="25" name="TextBox 24"/>
+          <p:cNvPr id="24" name="TextBox 23"/>
           <p:cNvSpPr txBox="1"/>
           <p:nvPr/>
         </p:nvSpPr>
@@ -10295,7 +10120,7 @@
       </p:sp>
       <p:sp>
         <p:nvSpPr>
-          <p:cNvPr id="26" name="Rectangle 25"/>
+          <p:cNvPr id="25" name="Rectangle 24"/>
           <p:cNvSpPr/>
           <p:nvPr/>
         </p:nvSpPr>
@@ -10339,7 +10164,7 @@
       </p:sp>
       <p:sp>
         <p:nvSpPr>
-          <p:cNvPr id="27" name="Rectangle 26"/>
+          <p:cNvPr id="26" name="Rectangle 25"/>
           <p:cNvSpPr/>
           <p:nvPr/>
         </p:nvSpPr>
@@ -10383,7 +10208,7 @@
       </p:sp>
       <p:sp>
         <p:nvSpPr>
-          <p:cNvPr id="28" name="TextBox 27"/>
+          <p:cNvPr id="27" name="TextBox 26"/>
           <p:cNvSpPr txBox="1"/>
           <p:nvPr/>
         </p:nvSpPr>
@@ -10428,7 +10253,7 @@
       </p:sp>
       <p:sp>
         <p:nvSpPr>
-          <p:cNvPr id="29" name="TextBox 28"/>
+          <p:cNvPr id="28" name="TextBox 27"/>
           <p:cNvSpPr txBox="1"/>
           <p:nvPr/>
         </p:nvSpPr>

</xml_diff>

<commit_message>
Redesign high-level diagram in dark EY-template style (Graphviz)
Replace the three-box high-level diagram with a single surface-level
'how the platform works' flow: User asks -> Contract360 Assistant ->
Knowledge Base -> grounded, cited answer. Dark navy canvas, dashed yellow
group containers, icons and labelled arrows, matching the house template.
Hosted on a dark navy slide; ship the diagram standalone as PNG/SVG/PDF.
Refresh PPTX/HTML/PDF and docs.

Co-Authored-By: Claude Opus 4.8 <noreply@anthropic.com>
Claude-Session: https://claude.ai/code/session_01JQVZ2FVwvC1NPNKyKDE48A
</commit_message>
<xml_diff>
--- a/presentation/Contract360_Manager_Deck.pptx
+++ b/presentation/Contract360_Manager_Deck.pptx
@@ -646,7 +646,7 @@
           <a:lstStyle/>
           <a:p>
             <a:r>
-              <a:t>Two pipelines over one shared Azure backbone. Ingestion runs once per contract: we parse the document, build a hierarchical tree, create clause-aware chunks with embeddings, and index them — optionally extracting a knowledge graph. At query time, an LLM router reads the question and picks the best retrieval strategy — tree search, graph lookup, or a hybrid — then Azure OpenAI generates an answer using only what was retrieved, with inline citations. Everything sits on Azure services we already operate.</a:t>
+              <a:t>Here's the whole platform in one picture. Two simple phases. ONBOARD, once per contract: you upload a PDF, and the system reads it, splits it into clauses, and makes it searchable. ASK, anytime: you ask a question in plain English, the AI finds the right clauses, and returns a clear answer with every point linked back to its source clause. The whole thing runs on Azure services we already operate — so the data never leaves our tenant. The detailed engineering view is on the next slide.</a:t>
             </a:r>
           </a:p>
         </p:txBody>
@@ -6336,13 +6336,13 @@
         <p:spPr>
           <a:xfrm>
             <a:off x="0" y="0"/>
-            <a:ext cx="12191695" cy="1078992"/>
+            <a:ext cx="12191695" cy="6858000"/>
           </a:xfrm>
           <a:prstGeom prst="rect">
             <a:avLst/>
           </a:prstGeom>
           <a:solidFill>
-            <a:srgbClr val="2E2E38"/>
+            <a:srgbClr val="1C1C3A"/>
           </a:solidFill>
           <a:ln>
             <a:noFill/>
@@ -6379,8 +6379,8 @@
         </p:nvSpPr>
         <p:spPr>
           <a:xfrm>
-            <a:off x="0" y="1078992"/>
-            <a:ext cx="12191695" cy="54864"/>
+            <a:off x="502920" y="384048"/>
+            <a:ext cx="5943600" cy="658368"/>
           </a:xfrm>
           <a:prstGeom prst="rect">
             <a:avLst/>
@@ -6423,8 +6423,8 @@
         </p:nvSpPr>
         <p:spPr>
           <a:xfrm>
-            <a:off x="502920" y="182880"/>
-            <a:ext cx="9144000" cy="274320"/>
+            <a:off x="685800" y="475488"/>
+            <a:ext cx="5669280" cy="502920"/>
           </a:xfrm>
           <a:prstGeom prst="rect">
             <a:avLst/>
@@ -6449,13 +6449,13 @@
               </a:spcAft>
             </a:pPr>
             <a:r>
-              <a:rPr sz="1100" b="1" i="0">
-                <a:solidFill>
-                  <a:srgbClr val="FFE600"/>
-                </a:solidFill>
-                <a:latin typeface="Arial"/>
-              </a:rPr>
-              <a:t>SLIDE 1 (CONT.) — HOW IT WORKS</a:t>
+              <a:rPr sz="2400" b="1" i="0">
+                <a:solidFill>
+                  <a:srgbClr val="2E2E38"/>
+                </a:solidFill>
+                <a:latin typeface="Arial"/>
+              </a:rPr>
+              <a:t>How the Platform Works</a:t>
             </a:r>
           </a:p>
         </p:txBody>
@@ -6468,8 +6468,8 @@
         </p:nvSpPr>
         <p:spPr>
           <a:xfrm>
-            <a:off x="502920" y="438912"/>
-            <a:ext cx="10515600" cy="548640"/>
+            <a:off x="521207" y="1115568"/>
+            <a:ext cx="10058400" cy="320040"/>
           </a:xfrm>
           <a:prstGeom prst="rect">
             <a:avLst/>
@@ -6494,13 +6494,13 @@
               </a:spcAft>
             </a:pPr>
             <a:r>
-              <a:rPr sz="2500" b="1" i="0">
-                <a:solidFill>
-                  <a:srgbClr val="FFFFFF"/>
-                </a:solidFill>
-                <a:latin typeface="Arial"/>
-              </a:rPr>
-              <a:t>High-Level Architecture</a:t>
+              <a:rPr sz="1100" b="1" i="0">
+                <a:solidFill>
+                  <a:srgbClr val="FFE600"/>
+                </a:solidFill>
+                <a:latin typeface="Arial"/>
+              </a:rPr>
+              <a:t>HOW IT WORKS  ·  CONTRACT360</a:t>
             </a:r>
           </a:p>
         </p:txBody>
@@ -6513,7 +6513,7 @@
         </p:nvSpPr>
         <p:spPr>
           <a:xfrm>
-            <a:off x="11201400" y="414223"/>
+            <a:off x="11201400" y="551383"/>
             <a:ext cx="559612" cy="108813"/>
           </a:xfrm>
           <a:prstGeom prst="parallelogram">
@@ -6551,9 +6551,366 @@
           </a:p>
         </p:txBody>
       </p:sp>
-      <p:sp>
-        <p:nvSpPr>
-          <p:cNvPr id="7" name="TextBox 6"/>
+      <p:pic>
+        <p:nvPicPr>
+          <p:cNvPr id="7" name="Picture 6" descr="hl_overview.png"/>
+          <p:cNvPicPr>
+            <a:picLocks noChangeAspect="1"/>
+          </p:cNvPicPr>
+          <p:nvPr/>
+        </p:nvPicPr>
+        <p:blipFill>
+          <a:blip r:embed="rId2"/>
+          <a:stretch>
+            <a:fillRect/>
+          </a:stretch>
+        </p:blipFill>
+        <p:spPr>
+          <a:xfrm>
+            <a:off x="3216293" y="1481328"/>
+            <a:ext cx="5756365" cy="3657600"/>
+          </a:xfrm>
+          <a:prstGeom prst="rect">
+            <a:avLst/>
+          </a:prstGeom>
+        </p:spPr>
+      </p:pic>
+      <p:sp>
+        <p:nvSpPr>
+          <p:cNvPr id="8" name="Rectangle 7"/>
+          <p:cNvSpPr/>
+          <p:nvPr/>
+        </p:nvSpPr>
+        <p:spPr>
+          <a:xfrm>
+            <a:off x="502920" y="5532120"/>
+            <a:ext cx="64008" cy="713232"/>
+          </a:xfrm>
+          <a:prstGeom prst="rect">
+            <a:avLst/>
+          </a:prstGeom>
+          <a:solidFill>
+            <a:srgbClr val="FFE600"/>
+          </a:solidFill>
+          <a:ln>
+            <a:noFill/>
+          </a:ln>
+          <a:effectLst/>
+        </p:spPr>
+        <p:style>
+          <a:lnRef idx="1">
+            <a:schemeClr val="accent1"/>
+          </a:lnRef>
+          <a:fillRef idx="3">
+            <a:schemeClr val="accent1"/>
+          </a:fillRef>
+          <a:effectRef idx="2">
+            <a:schemeClr val="accent1"/>
+          </a:effectRef>
+          <a:fontRef idx="minor">
+            <a:schemeClr val="lt1"/>
+          </a:fontRef>
+        </p:style>
+        <p:txBody>
+          <a:bodyPr rtlCol="0" anchor="ctr"/>
+          <a:lstStyle/>
+          <a:p>
+            <a:pPr algn="ctr"/>
+          </a:p>
+        </p:txBody>
+      </p:sp>
+      <p:sp>
+        <p:nvSpPr>
+          <p:cNvPr id="9" name="TextBox 8"/>
+          <p:cNvSpPr txBox="1"/>
+          <p:nvPr/>
+        </p:nvSpPr>
+        <p:spPr>
+          <a:xfrm>
+            <a:off x="667512" y="5532120"/>
+            <a:ext cx="3474720" cy="731520"/>
+          </a:xfrm>
+          <a:prstGeom prst="rect">
+            <a:avLst/>
+          </a:prstGeom>
+          <a:noFill/>
+        </p:spPr>
+        <p:txBody>
+          <a:bodyPr wrap="square" anchor="t" lIns="0" rIns="0" tIns="0" bIns="0">
+            <a:spAutoFit/>
+          </a:bodyPr>
+          <a:lstStyle/>
+          <a:p>
+            <a:pPr algn="l">
+              <a:lnSpc>
+                <a:spcPct val="100000"/>
+              </a:lnSpc>
+              <a:spcBef>
+                <a:spcPts val="0"/>
+              </a:spcBef>
+              <a:spcAft>
+                <a:spcPts val="200"/>
+              </a:spcAft>
+            </a:pPr>
+            <a:r>
+              <a:rPr sz="1100" b="1" i="0">
+                <a:solidFill>
+                  <a:srgbClr val="FFE600"/>
+                </a:solidFill>
+                <a:latin typeface="Arial"/>
+              </a:rPr>
+              <a:t>PLAIN-LANGUAGE ACCESS</a:t>
+            </a:r>
+          </a:p>
+          <a:p>
+            <a:pPr algn="l">
+              <a:lnSpc>
+                <a:spcPct val="100000"/>
+              </a:lnSpc>
+              <a:spcBef>
+                <a:spcPts val="0"/>
+              </a:spcBef>
+              <a:spcAft>
+                <a:spcPts val="200"/>
+              </a:spcAft>
+            </a:pPr>
+            <a:r>
+              <a:rPr sz="1000" b="0" i="0">
+                <a:solidFill>
+                  <a:srgbClr val="CFCFDA"/>
+                </a:solidFill>
+                <a:latin typeface="Arial"/>
+              </a:rPr>
+              <a:t>Anyone can interrogate a contract — no legal training needed.</a:t>
+            </a:r>
+          </a:p>
+        </p:txBody>
+      </p:sp>
+      <p:sp>
+        <p:nvSpPr>
+          <p:cNvPr id="10" name="Rectangle 9"/>
+          <p:cNvSpPr/>
+          <p:nvPr/>
+        </p:nvSpPr>
+        <p:spPr>
+          <a:xfrm>
+            <a:off x="4352544" y="5532120"/>
+            <a:ext cx="64008" cy="713232"/>
+          </a:xfrm>
+          <a:prstGeom prst="rect">
+            <a:avLst/>
+          </a:prstGeom>
+          <a:solidFill>
+            <a:srgbClr val="FFE600"/>
+          </a:solidFill>
+          <a:ln>
+            <a:noFill/>
+          </a:ln>
+          <a:effectLst/>
+        </p:spPr>
+        <p:style>
+          <a:lnRef idx="1">
+            <a:schemeClr val="accent1"/>
+          </a:lnRef>
+          <a:fillRef idx="3">
+            <a:schemeClr val="accent1"/>
+          </a:fillRef>
+          <a:effectRef idx="2">
+            <a:schemeClr val="accent1"/>
+          </a:effectRef>
+          <a:fontRef idx="minor">
+            <a:schemeClr val="lt1"/>
+          </a:fontRef>
+        </p:style>
+        <p:txBody>
+          <a:bodyPr rtlCol="0" anchor="ctr"/>
+          <a:lstStyle/>
+          <a:p>
+            <a:pPr algn="ctr"/>
+          </a:p>
+        </p:txBody>
+      </p:sp>
+      <p:sp>
+        <p:nvSpPr>
+          <p:cNvPr id="11" name="TextBox 10"/>
+          <p:cNvSpPr txBox="1"/>
+          <p:nvPr/>
+        </p:nvSpPr>
+        <p:spPr>
+          <a:xfrm>
+            <a:off x="4517136" y="5532120"/>
+            <a:ext cx="3474720" cy="731520"/>
+          </a:xfrm>
+          <a:prstGeom prst="rect">
+            <a:avLst/>
+          </a:prstGeom>
+          <a:noFill/>
+        </p:spPr>
+        <p:txBody>
+          <a:bodyPr wrap="square" anchor="t" lIns="0" rIns="0" tIns="0" bIns="0">
+            <a:spAutoFit/>
+          </a:bodyPr>
+          <a:lstStyle/>
+          <a:p>
+            <a:pPr algn="l">
+              <a:lnSpc>
+                <a:spcPct val="100000"/>
+              </a:lnSpc>
+              <a:spcBef>
+                <a:spcPts val="0"/>
+              </a:spcBef>
+              <a:spcAft>
+                <a:spcPts val="200"/>
+              </a:spcAft>
+            </a:pPr>
+            <a:r>
+              <a:rPr sz="1100" b="1" i="0">
+                <a:solidFill>
+                  <a:srgbClr val="FFE600"/>
+                </a:solidFill>
+                <a:latin typeface="Arial"/>
+              </a:rPr>
+              <a:t>GROUNDED &amp; AUDITABLE</a:t>
+            </a:r>
+          </a:p>
+          <a:p>
+            <a:pPr algn="l">
+              <a:lnSpc>
+                <a:spcPct val="100000"/>
+              </a:lnSpc>
+              <a:spcBef>
+                <a:spcPts val="0"/>
+              </a:spcBef>
+              <a:spcAft>
+                <a:spcPts val="200"/>
+              </a:spcAft>
+            </a:pPr>
+            <a:r>
+              <a:rPr sz="1000" b="0" i="0">
+                <a:solidFill>
+                  <a:srgbClr val="CFCFDA"/>
+                </a:solidFill>
+                <a:latin typeface="Arial"/>
+              </a:rPr>
+              <a:t>Every answer cites the exact source clause it came from.</a:t>
+            </a:r>
+          </a:p>
+        </p:txBody>
+      </p:sp>
+      <p:sp>
+        <p:nvSpPr>
+          <p:cNvPr id="12" name="Rectangle 11"/>
+          <p:cNvSpPr/>
+          <p:nvPr/>
+        </p:nvSpPr>
+        <p:spPr>
+          <a:xfrm>
+            <a:off x="8202168" y="5532120"/>
+            <a:ext cx="64008" cy="713232"/>
+          </a:xfrm>
+          <a:prstGeom prst="rect">
+            <a:avLst/>
+          </a:prstGeom>
+          <a:solidFill>
+            <a:srgbClr val="FFE600"/>
+          </a:solidFill>
+          <a:ln>
+            <a:noFill/>
+          </a:ln>
+          <a:effectLst/>
+        </p:spPr>
+        <p:style>
+          <a:lnRef idx="1">
+            <a:schemeClr val="accent1"/>
+          </a:lnRef>
+          <a:fillRef idx="3">
+            <a:schemeClr val="accent1"/>
+          </a:fillRef>
+          <a:effectRef idx="2">
+            <a:schemeClr val="accent1"/>
+          </a:effectRef>
+          <a:fontRef idx="minor">
+            <a:schemeClr val="lt1"/>
+          </a:fontRef>
+        </p:style>
+        <p:txBody>
+          <a:bodyPr rtlCol="0" anchor="ctr"/>
+          <a:lstStyle/>
+          <a:p>
+            <a:pPr algn="ctr"/>
+          </a:p>
+        </p:txBody>
+      </p:sp>
+      <p:sp>
+        <p:nvSpPr>
+          <p:cNvPr id="13" name="TextBox 12"/>
+          <p:cNvSpPr txBox="1"/>
+          <p:nvPr/>
+        </p:nvSpPr>
+        <p:spPr>
+          <a:xfrm>
+            <a:off x="8366760" y="5532120"/>
+            <a:ext cx="3474720" cy="731520"/>
+          </a:xfrm>
+          <a:prstGeom prst="rect">
+            <a:avLst/>
+          </a:prstGeom>
+          <a:noFill/>
+        </p:spPr>
+        <p:txBody>
+          <a:bodyPr wrap="square" anchor="t" lIns="0" rIns="0" tIns="0" bIns="0">
+            <a:spAutoFit/>
+          </a:bodyPr>
+          <a:lstStyle/>
+          <a:p>
+            <a:pPr algn="l">
+              <a:lnSpc>
+                <a:spcPct val="100000"/>
+              </a:lnSpc>
+              <a:spcBef>
+                <a:spcPts val="0"/>
+              </a:spcBef>
+              <a:spcAft>
+                <a:spcPts val="200"/>
+              </a:spcAft>
+            </a:pPr>
+            <a:r>
+              <a:rPr sz="1100" b="1" i="0">
+                <a:solidFill>
+                  <a:srgbClr val="FFE600"/>
+                </a:solidFill>
+                <a:latin typeface="Arial"/>
+              </a:rPr>
+              <a:t>AZURE-NATIVE</a:t>
+            </a:r>
+          </a:p>
+          <a:p>
+            <a:pPr algn="l">
+              <a:lnSpc>
+                <a:spcPct val="100000"/>
+              </a:lnSpc>
+              <a:spcBef>
+                <a:spcPts val="0"/>
+              </a:spcBef>
+              <a:spcAft>
+                <a:spcPts val="200"/>
+              </a:spcAft>
+            </a:pPr>
+            <a:r>
+              <a:rPr sz="1000" b="0" i="0">
+                <a:solidFill>
+                  <a:srgbClr val="CFCFDA"/>
+                </a:solidFill>
+                <a:latin typeface="Arial"/>
+              </a:rPr>
+              <a:t>Runs in our own cloud tenant — your data stays with you.</a:t>
+            </a:r>
+          </a:p>
+        </p:txBody>
+      </p:sp>
+      <p:sp>
+        <p:nvSpPr>
+          <p:cNvPr id="14" name="TextBox 13"/>
           <p:cNvSpPr txBox="1"/>
           <p:nvPr/>
         </p:nvSpPr>
@@ -6587,7 +6944,7 @@
             <a:r>
               <a:rPr sz="850" b="0" i="0">
                 <a:solidFill>
-                  <a:srgbClr val="747480"/>
+                  <a:srgbClr val="9A9AA6"/>
                 </a:solidFill>
                 <a:latin typeface="Arial"/>
               </a:rPr>
@@ -6598,7 +6955,7 @@
       </p:sp>
       <p:sp>
         <p:nvSpPr>
-          <p:cNvPr id="8" name="TextBox 7"/>
+          <p:cNvPr id="15" name="TextBox 14"/>
           <p:cNvSpPr txBox="1"/>
           <p:nvPr/>
         </p:nvSpPr>
@@ -6632,368 +6989,11 @@
             <a:r>
               <a:rPr sz="900" b="1" i="0">
                 <a:solidFill>
-                  <a:srgbClr val="747480"/>
+                  <a:srgbClr val="9A9AA6"/>
                 </a:solidFill>
                 <a:latin typeface="Arial"/>
               </a:rPr>
               <a:t>3</a:t>
-            </a:r>
-          </a:p>
-        </p:txBody>
-      </p:sp>
-      <p:pic>
-        <p:nvPicPr>
-          <p:cNvPr id="9" name="Picture 8" descr="hl_arch.png"/>
-          <p:cNvPicPr>
-            <a:picLocks noChangeAspect="1"/>
-          </p:cNvPicPr>
-          <p:nvPr/>
-        </p:nvPicPr>
-        <p:blipFill>
-          <a:blip r:embed="rId2"/>
-          <a:stretch>
-            <a:fillRect/>
-          </a:stretch>
-        </p:blipFill>
-        <p:spPr>
-          <a:xfrm>
-            <a:off x="2411307" y="1371600"/>
-            <a:ext cx="7384626" cy="4069080"/>
-          </a:xfrm>
-          <a:prstGeom prst="rect">
-            <a:avLst/>
-          </a:prstGeom>
-        </p:spPr>
-      </p:pic>
-      <p:sp>
-        <p:nvSpPr>
-          <p:cNvPr id="10" name="Rectangle 9"/>
-          <p:cNvSpPr/>
-          <p:nvPr/>
-        </p:nvSpPr>
-        <p:spPr>
-          <a:xfrm>
-            <a:off x="502920" y="5532120"/>
-            <a:ext cx="64008" cy="713232"/>
-          </a:xfrm>
-          <a:prstGeom prst="rect">
-            <a:avLst/>
-          </a:prstGeom>
-          <a:solidFill>
-            <a:srgbClr val="FFE600"/>
-          </a:solidFill>
-          <a:ln>
-            <a:noFill/>
-          </a:ln>
-          <a:effectLst/>
-        </p:spPr>
-        <p:style>
-          <a:lnRef idx="1">
-            <a:schemeClr val="accent1"/>
-          </a:lnRef>
-          <a:fillRef idx="3">
-            <a:schemeClr val="accent1"/>
-          </a:fillRef>
-          <a:effectRef idx="2">
-            <a:schemeClr val="accent1"/>
-          </a:effectRef>
-          <a:fontRef idx="minor">
-            <a:schemeClr val="lt1"/>
-          </a:fontRef>
-        </p:style>
-        <p:txBody>
-          <a:bodyPr rtlCol="0" anchor="ctr"/>
-          <a:lstStyle/>
-          <a:p>
-            <a:pPr algn="ctr"/>
-          </a:p>
-        </p:txBody>
-      </p:sp>
-      <p:sp>
-        <p:nvSpPr>
-          <p:cNvPr id="11" name="TextBox 10"/>
-          <p:cNvSpPr txBox="1"/>
-          <p:nvPr/>
-        </p:nvSpPr>
-        <p:spPr>
-          <a:xfrm>
-            <a:off x="667512" y="5532120"/>
-            <a:ext cx="3474720" cy="731520"/>
-          </a:xfrm>
-          <a:prstGeom prst="rect">
-            <a:avLst/>
-          </a:prstGeom>
-          <a:noFill/>
-        </p:spPr>
-        <p:txBody>
-          <a:bodyPr wrap="square" anchor="t" lIns="0" rIns="0" tIns="0" bIns="0">
-            <a:spAutoFit/>
-          </a:bodyPr>
-          <a:lstStyle/>
-          <a:p>
-            <a:pPr algn="l">
-              <a:lnSpc>
-                <a:spcPct val="100000"/>
-              </a:lnSpc>
-              <a:spcBef>
-                <a:spcPts val="0"/>
-              </a:spcBef>
-              <a:spcAft>
-                <a:spcPts val="200"/>
-              </a:spcAft>
-            </a:pPr>
-            <a:r>
-              <a:rPr sz="1100" b="1" i="0">
-                <a:solidFill>
-                  <a:srgbClr val="2E2E38"/>
-                </a:solidFill>
-                <a:latin typeface="Arial"/>
-              </a:rPr>
-              <a:t>INGEST ONCE</a:t>
-            </a:r>
-          </a:p>
-          <a:p>
-            <a:pPr algn="l">
-              <a:lnSpc>
-                <a:spcPct val="100000"/>
-              </a:lnSpc>
-              <a:spcBef>
-                <a:spcPts val="0"/>
-              </a:spcBef>
-              <a:spcAft>
-                <a:spcPts val="200"/>
-              </a:spcAft>
-            </a:pPr>
-            <a:r>
-              <a:rPr sz="1000" b="0" i="0">
-                <a:solidFill>
-                  <a:srgbClr val="747480"/>
-                </a:solidFill>
-                <a:latin typeface="Arial"/>
-              </a:rPr>
-              <a:t>Parse → tree → clause chunks + embeddings → searchable index.</a:t>
-            </a:r>
-          </a:p>
-        </p:txBody>
-      </p:sp>
-      <p:sp>
-        <p:nvSpPr>
-          <p:cNvPr id="12" name="Rectangle 11"/>
-          <p:cNvSpPr/>
-          <p:nvPr/>
-        </p:nvSpPr>
-        <p:spPr>
-          <a:xfrm>
-            <a:off x="4352544" y="5532120"/>
-            <a:ext cx="64008" cy="713232"/>
-          </a:xfrm>
-          <a:prstGeom prst="rect">
-            <a:avLst/>
-          </a:prstGeom>
-          <a:solidFill>
-            <a:srgbClr val="FFE600"/>
-          </a:solidFill>
-          <a:ln>
-            <a:noFill/>
-          </a:ln>
-          <a:effectLst/>
-        </p:spPr>
-        <p:style>
-          <a:lnRef idx="1">
-            <a:schemeClr val="accent1"/>
-          </a:lnRef>
-          <a:fillRef idx="3">
-            <a:schemeClr val="accent1"/>
-          </a:fillRef>
-          <a:effectRef idx="2">
-            <a:schemeClr val="accent1"/>
-          </a:effectRef>
-          <a:fontRef idx="minor">
-            <a:schemeClr val="lt1"/>
-          </a:fontRef>
-        </p:style>
-        <p:txBody>
-          <a:bodyPr rtlCol="0" anchor="ctr"/>
-          <a:lstStyle/>
-          <a:p>
-            <a:pPr algn="ctr"/>
-          </a:p>
-        </p:txBody>
-      </p:sp>
-      <p:sp>
-        <p:nvSpPr>
-          <p:cNvPr id="13" name="TextBox 12"/>
-          <p:cNvSpPr txBox="1"/>
-          <p:nvPr/>
-        </p:nvSpPr>
-        <p:spPr>
-          <a:xfrm>
-            <a:off x="4517136" y="5532120"/>
-            <a:ext cx="3474720" cy="731520"/>
-          </a:xfrm>
-          <a:prstGeom prst="rect">
-            <a:avLst/>
-          </a:prstGeom>
-          <a:noFill/>
-        </p:spPr>
-        <p:txBody>
-          <a:bodyPr wrap="square" anchor="t" lIns="0" rIns="0" tIns="0" bIns="0">
-            <a:spAutoFit/>
-          </a:bodyPr>
-          <a:lstStyle/>
-          <a:p>
-            <a:pPr algn="l">
-              <a:lnSpc>
-                <a:spcPct val="100000"/>
-              </a:lnSpc>
-              <a:spcBef>
-                <a:spcPts val="0"/>
-              </a:spcBef>
-              <a:spcAft>
-                <a:spcPts val="200"/>
-              </a:spcAft>
-            </a:pPr>
-            <a:r>
-              <a:rPr sz="1100" b="1" i="0">
-                <a:solidFill>
-                  <a:srgbClr val="2E2E38"/>
-                </a:solidFill>
-                <a:latin typeface="Arial"/>
-              </a:rPr>
-              <a:t>ROUTE EACH QUERY</a:t>
-            </a:r>
-          </a:p>
-          <a:p>
-            <a:pPr algn="l">
-              <a:lnSpc>
-                <a:spcPct val="100000"/>
-              </a:lnSpc>
-              <a:spcBef>
-                <a:spcPts val="0"/>
-              </a:spcBef>
-              <a:spcAft>
-                <a:spcPts val="200"/>
-              </a:spcAft>
-            </a:pPr>
-            <a:r>
-              <a:rPr sz="1000" b="0" i="0">
-                <a:solidFill>
-                  <a:srgbClr val="747480"/>
-                </a:solidFill>
-                <a:latin typeface="Arial"/>
-              </a:rPr>
-              <a:t>An LLM router picks tree, graph or hybrid retrieval per question.</a:t>
-            </a:r>
-          </a:p>
-        </p:txBody>
-      </p:sp>
-      <p:sp>
-        <p:nvSpPr>
-          <p:cNvPr id="14" name="Rectangle 13"/>
-          <p:cNvSpPr/>
-          <p:nvPr/>
-        </p:nvSpPr>
-        <p:spPr>
-          <a:xfrm>
-            <a:off x="8202168" y="5532120"/>
-            <a:ext cx="64008" cy="713232"/>
-          </a:xfrm>
-          <a:prstGeom prst="rect">
-            <a:avLst/>
-          </a:prstGeom>
-          <a:solidFill>
-            <a:srgbClr val="FFE600"/>
-          </a:solidFill>
-          <a:ln>
-            <a:noFill/>
-          </a:ln>
-          <a:effectLst/>
-        </p:spPr>
-        <p:style>
-          <a:lnRef idx="1">
-            <a:schemeClr val="accent1"/>
-          </a:lnRef>
-          <a:fillRef idx="3">
-            <a:schemeClr val="accent1"/>
-          </a:fillRef>
-          <a:effectRef idx="2">
-            <a:schemeClr val="accent1"/>
-          </a:effectRef>
-          <a:fontRef idx="minor">
-            <a:schemeClr val="lt1"/>
-          </a:fontRef>
-        </p:style>
-        <p:txBody>
-          <a:bodyPr rtlCol="0" anchor="ctr"/>
-          <a:lstStyle/>
-          <a:p>
-            <a:pPr algn="ctr"/>
-          </a:p>
-        </p:txBody>
-      </p:sp>
-      <p:sp>
-        <p:nvSpPr>
-          <p:cNvPr id="15" name="TextBox 14"/>
-          <p:cNvSpPr txBox="1"/>
-          <p:nvPr/>
-        </p:nvSpPr>
-        <p:spPr>
-          <a:xfrm>
-            <a:off x="8366760" y="5532120"/>
-            <a:ext cx="3474720" cy="731520"/>
-          </a:xfrm>
-          <a:prstGeom prst="rect">
-            <a:avLst/>
-          </a:prstGeom>
-          <a:noFill/>
-        </p:spPr>
-        <p:txBody>
-          <a:bodyPr wrap="square" anchor="t" lIns="0" rIns="0" tIns="0" bIns="0">
-            <a:spAutoFit/>
-          </a:bodyPr>
-          <a:lstStyle/>
-          <a:p>
-            <a:pPr algn="l">
-              <a:lnSpc>
-                <a:spcPct val="100000"/>
-              </a:lnSpc>
-              <a:spcBef>
-                <a:spcPts val="0"/>
-              </a:spcBef>
-              <a:spcAft>
-                <a:spcPts val="200"/>
-              </a:spcAft>
-            </a:pPr>
-            <a:r>
-              <a:rPr sz="1100" b="1" i="0">
-                <a:solidFill>
-                  <a:srgbClr val="2E2E38"/>
-                </a:solidFill>
-                <a:latin typeface="Arial"/>
-              </a:rPr>
-              <a:t>ANSWER, GROUNDED</a:t>
-            </a:r>
-          </a:p>
-          <a:p>
-            <a:pPr algn="l">
-              <a:lnSpc>
-                <a:spcPct val="100000"/>
-              </a:lnSpc>
-              <a:spcBef>
-                <a:spcPts val="0"/>
-              </a:spcBef>
-              <a:spcAft>
-                <a:spcPts val="200"/>
-              </a:spcAft>
-            </a:pPr>
-            <a:r>
-              <a:rPr sz="1000" b="0" i="0">
-                <a:solidFill>
-                  <a:srgbClr val="747480"/>
-                </a:solidFill>
-                <a:latin typeface="Arial"/>
-              </a:rPr>
-              <a:t>Azure OpenAI answers only from retrieved context — with citations.</a:t>
             </a:r>
           </a:p>
         </p:txBody>

</xml_diff>

<commit_message>
Surface knowledge graph on high-level diagram
Split the Knowledge Base into 'Clause search' and 'Knowledge graph'
(obligations, parties, deadlines & links), with the assistant doing
smart retrieval. Keeps the high-level lighter than the detailed router
(search/graph/hybrid/tree) while showing the differentiator in business
terms. Regenerate diagram, decks and PDF.

Co-Authored-By: Claude Opus 4.8 <noreply@anthropic.com>
Claude-Session: https://claude.ai/code/session_01JQVZ2FVwvC1NPNKyKDE48A
</commit_message>
<xml_diff>
--- a/presentation/Contract360_Manager_Deck.pptx
+++ b/presentation/Contract360_Manager_Deck.pptx
@@ -6567,8 +6567,8 @@
         </p:blipFill>
         <p:spPr>
           <a:xfrm>
-            <a:off x="3216293" y="1481328"/>
-            <a:ext cx="5756365" cy="3657600"/>
+            <a:off x="3229356" y="1481328"/>
+            <a:ext cx="5730240" cy="3657600"/>
           </a:xfrm>
           <a:prstGeom prst="rect">
             <a:avLst/>

</xml_diff>